<commit_message>
Reorder the plan around the head-to-head that decides the paper
FOCUS evaluates on Qwen2.5-VL 3B and 7B — the same models we use — and releases
its code, so putting our method on MuirBench and Mantis-Eval settles the public
benchmark question and the baseline comparison in one run rather than two
separate phases months apart. That moves to weeks 1-2, the model-family port
picks up InternVL3 and LLaVA-OneVision because FOCUS reports those too, and the
generative evaluation targets Winoground and VisMin, both two-image benchmarks
where our reconstruction was already valid.

The stopping rule is restated in terms of that comparison: losing to FOCUS on
its own benchmarks with its own code turns this into a mechanism paper rather
than a method paper.

Co-Authored-By: Claude Fable 5 <noreply@anthropic.com>
</commit_message>
<xml_diff>
--- a/meeting/SourceDepth_8.26_v10.pptx
+++ b/meeting/SourceDepth_8.26_v10.pptx
@@ -1036,7 +1036,7 @@
           <a:p>
             <a:r>
               <a:rPr lang="en-US" dirty="0"/>
-              <a:t>11주 남았습니다. 이번 주 발견에서 바로 나온 실험 두 가지를 먼저 하고, 1, 2주차 공개 벤치마크가 중단 조건입니다. 지금 결과가 전부 자체 제작 벤치와 예아니오 단답에 한정되어 있어서, 거기서 재현 안 되면 접겠습니다.</a:t>
+              <a:t>가장 중요한 다음 단계는 경쟁 방법과 같은 벤치, 같은 모델에서 직접 붙는 것입니다. 다행히 FOCUS가 저희와 같은 Qwen2.5-VL 3B, 7B로 공개 벤치마크를 평가했고 코드도 공개돼 있습니다. 같은 벤치에 저희 방법을 올리면 공개 벤치 검증과 FOCUS 직접 비교가 한 번에 끝납니다. 여기서 밀리면 방법 논문이 아니라 기전 분석 논문으로 방향을 바꾸겠습니다.</a:t>
             </a:r>
             <a:endParaRPr lang="en-US" dirty="0"/>
           </a:p>
@@ -4838,7 +4838,7 @@
                 <a:ea typeface="Arial" pitchFamily="34" charset="-122"/>
                 <a:cs typeface="Arial" pitchFamily="34" charset="-120"/>
               </a:rPr>
-              <a:t>CVPR 2027 마감까지 11주 — 중단 조건을 먼저 둡니다</a:t>
+              <a:t>경쟁 방법과 같은 벤치·같은 모델에서 직접 붙이는 것이 최우선입니다</a:t>
             </a:r>
             <a:endParaRPr lang="en-US" sz="2200" dirty="0"/>
           </a:p>
@@ -4852,12 +4852,12 @@
         </p:nvSpPr>
         <p:spPr>
           <a:xfrm>
-            <a:off x="502920" y="1188720"/>
-            <a:ext cx="11201400" cy="1170432"/>
+            <a:off x="502920" y="1170432"/>
+            <a:ext cx="11201400" cy="1298448"/>
           </a:xfrm>
           <a:prstGeom prst="roundRect">
             <a:avLst>
-              <a:gd name="adj" fmla="val 4688"/>
+              <a:gd name="adj" fmla="val 4225"/>
             </a:avLst>
           </a:prstGeom>
           <a:solidFill>
@@ -4879,7 +4879,7 @@
         </p:nvSpPr>
         <p:spPr>
           <a:xfrm>
-            <a:off x="777240" y="1298448"/>
+            <a:off x="777240" y="1280160"/>
             <a:ext cx="10698480" cy="274320"/>
           </a:xfrm>
           <a:prstGeom prst="rect">
@@ -4904,7 +4904,7 @@
                 <a:ea typeface="Arial" pitchFamily="34" charset="-122"/>
                 <a:cs typeface="Arial" pitchFamily="34" charset="-120"/>
               </a:rPr>
-              <a:t>이번 주 발견에서 바로 나온 다음 실험</a:t>
+              <a:t>FOCUS는 우리와 같은 모델(Qwen2.5-VL 3B / 7B)로 공개 벤치마크를 평가했습니다</a:t>
             </a:r>
             <a:endParaRPr lang="en-US" sz="1300" dirty="0"/>
           </a:p>
@@ -4918,23 +4918,20 @@
         </p:nvSpPr>
         <p:spPr>
           <a:xfrm>
-            <a:off x="777240" y="1609344"/>
-            <a:ext cx="10698480" cy="621792"/>
-          </a:xfrm>
-          <a:prstGeom prst="rect">
-            <a:avLst/>
-          </a:prstGeom>
-          <a:noFill/>
-          <a:ln/>
-        </p:spPr>
-        <p:txBody>
-          <a:bodyPr wrap="square" lIns="0" tIns="0" rIns="0" bIns="0" rtlCol="0" anchor="ctr"/>
-          <a:lstStyle/>
-          <a:p>
-            <a:pPr indent="0" marL="0">
-              <a:lnSpc>
-                <a:spcPct val="130000"/>
-              </a:lnSpc>
+            <a:off x="777240" y="1591056"/>
+            <a:ext cx="10698480" cy="274320"/>
+          </a:xfrm>
+          <a:prstGeom prst="rect">
+            <a:avLst/>
+          </a:prstGeom>
+          <a:noFill/>
+          <a:ln/>
+        </p:spPr>
+        <p:txBody>
+          <a:bodyPr wrap="square" lIns="0" tIns="0" rIns="0" bIns="0" rtlCol="0" anchor="ctr"/>
+          <a:lstStyle/>
+          <a:p>
+            <a:pPr indent="0" marL="0">
               <a:buNone/>
             </a:pPr>
             <a:r>
@@ -4946,46 +4943,65 @@
                 <a:ea typeface="Arial" pitchFamily="34" charset="-122"/>
                 <a:cs typeface="Arial" pitchFamily="34" charset="-120"/>
               </a:rPr>
-              <a:t>① 적응형 개수 — 1·2위 영향도가 비슷하면 두 장 다 남긴다 (문항마다 남길 개수를 다르게)</a:t>
+              <a:t>MuirBench +3.2%p  ·  Mantis-Eval +5.5%p  ·  MIRB +1.7%p  ·  Winoground · VisMin  (공식 코드 공개됨)</a:t>
             </a:r>
             <a:endParaRPr lang="en-US" sz="1200" dirty="0"/>
           </a:p>
-          <a:p>
-            <a:pPr indent="0" marL="0">
-              <a:lnSpc>
-                <a:spcPct val="130000"/>
-              </a:lnSpc>
-              <a:buNone/>
-            </a:pPr>
-            <a:r>
-              <a:rPr lang="en-US" sz="1200" dirty="0">
-                <a:solidFill>
-                  <a:srgbClr val="FFFFFF"/>
-                </a:solidFill>
-                <a:latin typeface="Arial" pitchFamily="34" charset="0"/>
-                <a:ea typeface="Arial" pitchFamily="34" charset="-122"/>
-                <a:cs typeface="Arial" pitchFamily="34" charset="-120"/>
-              </a:rPr>
-              <a:t>② 비례 차단 — 아예 끊거나 안 끊거나가 아니라, 관련도에 비례해 차단 강도를 조절한다</a:t>
-            </a:r>
-            <a:endParaRPr lang="en-US" sz="1200" dirty="0"/>
-          </a:p>
-        </p:txBody>
-      </p:sp>
-      <p:sp>
-        <p:nvSpPr>
-          <p:cNvPr id="7" name="Shape 5"/>
-          <p:cNvSpPr/>
-          <p:nvPr/>
-        </p:nvSpPr>
-        <p:spPr>
-          <a:xfrm>
-            <a:off x="502920" y="2523744"/>
-            <a:ext cx="11201400" cy="640080"/>
+        </p:txBody>
+      </p:sp>
+      <p:sp>
+        <p:nvSpPr>
+          <p:cNvPr id="7" name="Text 5"/>
+          <p:cNvSpPr/>
+          <p:nvPr/>
+        </p:nvSpPr>
+        <p:spPr>
+          <a:xfrm>
+            <a:off x="777240" y="1920240"/>
+            <a:ext cx="10698480" cy="292608"/>
+          </a:xfrm>
+          <a:prstGeom prst="rect">
+            <a:avLst/>
+          </a:prstGeom>
+          <a:noFill/>
+          <a:ln/>
+        </p:spPr>
+        <p:txBody>
+          <a:bodyPr wrap="square" lIns="0" tIns="0" rIns="0" bIns="0" rtlCol="0" anchor="ctr"/>
+          <a:lstStyle/>
+          <a:p>
+            <a:pPr indent="0" marL="0">
+              <a:buNone/>
+            </a:pPr>
+            <a:r>
+              <a:rPr lang="en-US" sz="1250" b="1" dirty="0">
+                <a:solidFill>
+                  <a:srgbClr val="8CE0B0"/>
+                </a:solidFill>
+                <a:latin typeface="Arial" pitchFamily="34" charset="0"/>
+                <a:ea typeface="Arial" pitchFamily="34" charset="-122"/>
+                <a:cs typeface="Arial" pitchFamily="34" charset="-120"/>
+              </a:rPr>
+              <a:t>→ 같은 벤치에 우리 방법을 올리면 '공개 벤치 검증'과 'FOCUS 직접 비교'가 한 번에 끝납니다. 이게 1순위입니다.</a:t>
+            </a:r>
+            <a:endParaRPr lang="en-US" sz="1250" dirty="0"/>
+          </a:p>
+        </p:txBody>
+      </p:sp>
+      <p:sp>
+        <p:nvSpPr>
+          <p:cNvPr id="8" name="Shape 6"/>
+          <p:cNvSpPr/>
+          <p:nvPr/>
+        </p:nvSpPr>
+        <p:spPr>
+          <a:xfrm>
+            <a:off x="502920" y="2615184"/>
+            <a:ext cx="11201400" cy="512064"/>
           </a:xfrm>
           <a:prstGeom prst="roundRect">
             <a:avLst>
-              <a:gd name="adj" fmla="val 8571"/>
+              <a:gd name="adj" fmla="val 10714"/>
             </a:avLst>
           </a:prstGeom>
           <a:solidFill>
@@ -5001,30 +5017,30 @@
       </p:sp>
       <p:sp>
         <p:nvSpPr>
-          <p:cNvPr id="8" name="Text 6"/>
-          <p:cNvSpPr/>
-          <p:nvPr/>
-        </p:nvSpPr>
-        <p:spPr>
-          <a:xfrm>
-            <a:off x="731520" y="2523744"/>
-            <a:ext cx="1188720" cy="640080"/>
-          </a:xfrm>
-          <a:prstGeom prst="rect">
-            <a:avLst/>
-          </a:prstGeom>
-          <a:noFill/>
-          <a:ln/>
-        </p:spPr>
-        <p:txBody>
-          <a:bodyPr wrap="square" lIns="0" tIns="0" rIns="0" bIns="0" rtlCol="0" anchor="ctr"/>
-          <a:lstStyle/>
-          <a:p>
-            <a:pPr indent="0" marL="0">
-              <a:buNone/>
-            </a:pPr>
-            <a:r>
-              <a:rPr lang="en-US" sz="1250" b="1" dirty="0">
+          <p:cNvPr id="9" name="Text 7"/>
+          <p:cNvSpPr/>
+          <p:nvPr/>
+        </p:nvSpPr>
+        <p:spPr>
+          <a:xfrm>
+            <a:off x="731520" y="2615184"/>
+            <a:ext cx="1143000" cy="512064"/>
+          </a:xfrm>
+          <a:prstGeom prst="rect">
+            <a:avLst/>
+          </a:prstGeom>
+          <a:noFill/>
+          <a:ln/>
+        </p:spPr>
+        <p:txBody>
+          <a:bodyPr wrap="square" lIns="0" tIns="0" rIns="0" bIns="0" rtlCol="0" anchor="ctr"/>
+          <a:lstStyle/>
+          <a:p>
+            <a:pPr indent="0" marL="0">
+              <a:buNone/>
+            </a:pPr>
+            <a:r>
+              <a:rPr lang="en-US" sz="1200" b="1" dirty="0">
                 <a:solidFill>
                   <a:srgbClr val="FF9E80"/>
                 </a:solidFill>
@@ -5034,36 +5050,36 @@
               </a:rPr>
               <a:t>1–2주</a:t>
             </a:r>
-            <a:endParaRPr lang="en-US" sz="1250" dirty="0"/>
-          </a:p>
-        </p:txBody>
-      </p:sp>
-      <p:sp>
-        <p:nvSpPr>
-          <p:cNvPr id="9" name="Text 7"/>
-          <p:cNvSpPr/>
-          <p:nvPr/>
-        </p:nvSpPr>
-        <p:spPr>
-          <a:xfrm>
-            <a:off x="2057400" y="2523744"/>
-            <a:ext cx="5943600" cy="640080"/>
-          </a:xfrm>
-          <a:prstGeom prst="rect">
-            <a:avLst/>
-          </a:prstGeom>
-          <a:noFill/>
-          <a:ln/>
-        </p:spPr>
-        <p:txBody>
-          <a:bodyPr wrap="square" lIns="0" tIns="0" rIns="0" bIns="0" rtlCol="0" anchor="ctr"/>
-          <a:lstStyle/>
-          <a:p>
-            <a:pPr indent="0" marL="0">
-              <a:buNone/>
-            </a:pPr>
-            <a:r>
-              <a:rPr lang="en-US" sz="1150" dirty="0">
+            <a:endParaRPr lang="en-US" sz="1200" dirty="0"/>
+          </a:p>
+        </p:txBody>
+      </p:sp>
+      <p:sp>
+        <p:nvSpPr>
+          <p:cNvPr id="10" name="Text 8"/>
+          <p:cNvSpPr/>
+          <p:nvPr/>
+        </p:nvSpPr>
+        <p:spPr>
+          <a:xfrm>
+            <a:off x="2011680" y="2615184"/>
+            <a:ext cx="6035040" cy="512064"/>
+          </a:xfrm>
+          <a:prstGeom prst="rect">
+            <a:avLst/>
+          </a:prstGeom>
+          <a:noFill/>
+          <a:ln/>
+        </p:spPr>
+        <p:txBody>
+          <a:bodyPr wrap="square" lIns="0" tIns="0" rIns="0" bIns="0" rtlCol="0" anchor="ctr"/>
+          <a:lstStyle/>
+          <a:p>
+            <a:pPr indent="0" marL="0">
+              <a:buNone/>
+            </a:pPr>
+            <a:r>
+              <a:rPr lang="en-US" sz="1100" dirty="0">
                 <a:solidFill>
                   <a:srgbClr val="FFFFFF"/>
                 </a:solidFill>
@@ -5071,38 +5087,38 @@
                 <a:ea typeface="Arial" pitchFamily="34" charset="-122"/>
                 <a:cs typeface="Arial" pitchFamily="34" charset="-120"/>
               </a:rPr>
-              <a:t>공개 벤치마크 검증 (MuirBench · BLINK)</a:t>
-            </a:r>
-            <a:endParaRPr lang="en-US" sz="1150" dirty="0"/>
-          </a:p>
-        </p:txBody>
-      </p:sp>
-      <p:sp>
-        <p:nvSpPr>
-          <p:cNvPr id="10" name="Text 8"/>
-          <p:cNvSpPr/>
-          <p:nvPr/>
-        </p:nvSpPr>
-        <p:spPr>
-          <a:xfrm>
-            <a:off x="8183880" y="2523744"/>
-            <a:ext cx="3383280" cy="640080"/>
-          </a:xfrm>
-          <a:prstGeom prst="rect">
-            <a:avLst/>
-          </a:prstGeom>
-          <a:noFill/>
-          <a:ln/>
-        </p:spPr>
-        <p:txBody>
-          <a:bodyPr wrap="square" lIns="0" tIns="0" rIns="0" bIns="0" rtlCol="0" anchor="ctr"/>
-          <a:lstStyle/>
-          <a:p>
-            <a:pPr indent="0" marL="0">
-              <a:buNone/>
-            </a:pPr>
-            <a:r>
-              <a:rPr lang="en-US" sz="1050" dirty="0">
+              <a:t>MuirBench · Mantis-Eval 에 우리 방법 + FOCUS 공식 코드를 같은 조건으로</a:t>
+            </a:r>
+            <a:endParaRPr lang="en-US" sz="1100" dirty="0"/>
+          </a:p>
+        </p:txBody>
+      </p:sp>
+      <p:sp>
+        <p:nvSpPr>
+          <p:cNvPr id="11" name="Text 9"/>
+          <p:cNvSpPr/>
+          <p:nvPr/>
+        </p:nvSpPr>
+        <p:spPr>
+          <a:xfrm>
+            <a:off x="8183880" y="2615184"/>
+            <a:ext cx="3383280" cy="512064"/>
+          </a:xfrm>
+          <a:prstGeom prst="rect">
+            <a:avLst/>
+          </a:prstGeom>
+          <a:noFill/>
+          <a:ln/>
+        </p:spPr>
+        <p:txBody>
+          <a:bodyPr wrap="square" lIns="0" tIns="0" rIns="0" bIns="0" rtlCol="0" anchor="ctr"/>
+          <a:lstStyle/>
+          <a:p>
+            <a:pPr indent="0" marL="0">
+              <a:buNone/>
+            </a:pPr>
+            <a:r>
+              <a:rPr lang="en-US" sz="1000" dirty="0">
                 <a:solidFill>
                   <a:srgbClr val="9FB8CE"/>
                 </a:solidFill>
@@ -5110,26 +5126,26 @@
                 <a:ea typeface="Arial" pitchFamily="34" charset="-122"/>
                 <a:cs typeface="Arial" pitchFamily="34" charset="-120"/>
               </a:rPr>
-              <a:t>→ ★ 핵심 단계 — 재현 안 되면 접습니다</a:t>
-            </a:r>
-            <a:endParaRPr lang="en-US" sz="1050" dirty="0"/>
-          </a:p>
-        </p:txBody>
-      </p:sp>
-      <p:sp>
-        <p:nvSpPr>
-          <p:cNvPr id="11" name="Shape 9"/>
-          <p:cNvSpPr/>
-          <p:nvPr/>
-        </p:nvSpPr>
-        <p:spPr>
-          <a:xfrm>
-            <a:off x="502920" y="3273552"/>
-            <a:ext cx="11201400" cy="640080"/>
+              <a:t>→ ★ 여기서 밀리면 방향을 바꿉니다</a:t>
+            </a:r>
+            <a:endParaRPr lang="en-US" sz="1000" dirty="0"/>
+          </a:p>
+        </p:txBody>
+      </p:sp>
+      <p:sp>
+        <p:nvSpPr>
+          <p:cNvPr id="12" name="Shape 10"/>
+          <p:cNvSpPr/>
+          <p:nvPr/>
+        </p:nvSpPr>
+        <p:spPr>
+          <a:xfrm>
+            <a:off x="502920" y="3218688"/>
+            <a:ext cx="11201400" cy="512064"/>
           </a:xfrm>
           <a:prstGeom prst="roundRect">
             <a:avLst>
-              <a:gd name="adj" fmla="val 8571"/>
+              <a:gd name="adj" fmla="val 10714"/>
             </a:avLst>
           </a:prstGeom>
           <a:solidFill>
@@ -5145,69 +5161,69 @@
       </p:sp>
       <p:sp>
         <p:nvSpPr>
-          <p:cNvPr id="12" name="Text 10"/>
-          <p:cNvSpPr/>
-          <p:nvPr/>
-        </p:nvSpPr>
-        <p:spPr>
-          <a:xfrm>
-            <a:off x="731520" y="3273552"/>
-            <a:ext cx="1188720" cy="640080"/>
-          </a:xfrm>
-          <a:prstGeom prst="rect">
-            <a:avLst/>
-          </a:prstGeom>
-          <a:noFill/>
-          <a:ln/>
-        </p:spPr>
-        <p:txBody>
-          <a:bodyPr wrap="square" lIns="0" tIns="0" rIns="0" bIns="0" rtlCol="0" anchor="ctr"/>
-          <a:lstStyle/>
-          <a:p>
-            <a:pPr indent="0" marL="0">
-              <a:buNone/>
-            </a:pPr>
-            <a:r>
-              <a:rPr lang="en-US" sz="1250" b="1" dirty="0">
-                <a:solidFill>
-                  <a:srgbClr val="7EC8F5"/>
-                </a:solidFill>
-                <a:latin typeface="Arial" pitchFamily="34" charset="0"/>
-                <a:ea typeface="Arial" pitchFamily="34" charset="-122"/>
-                <a:cs typeface="Arial" pitchFamily="34" charset="-120"/>
-              </a:rPr>
-              <a:t>3–4주</a:t>
-            </a:r>
-            <a:endParaRPr lang="en-US" sz="1250" dirty="0"/>
-          </a:p>
-        </p:txBody>
-      </p:sp>
-      <p:sp>
-        <p:nvSpPr>
           <p:cNvPr id="13" name="Text 11"/>
           <p:cNvSpPr/>
           <p:nvPr/>
         </p:nvSpPr>
         <p:spPr>
           <a:xfrm>
-            <a:off x="2057400" y="3273552"/>
-            <a:ext cx="5943600" cy="640080"/>
-          </a:xfrm>
-          <a:prstGeom prst="rect">
-            <a:avLst/>
-          </a:prstGeom>
-          <a:noFill/>
-          <a:ln/>
-        </p:spPr>
-        <p:txBody>
-          <a:bodyPr wrap="square" lIns="0" tIns="0" rIns="0" bIns="0" rtlCol="0" anchor="ctr"/>
-          <a:lstStyle/>
-          <a:p>
-            <a:pPr indent="0" marL="0">
-              <a:buNone/>
-            </a:pPr>
-            <a:r>
-              <a:rPr lang="en-US" sz="1150" dirty="0">
+            <a:off x="731520" y="3218688"/>
+            <a:ext cx="1143000" cy="512064"/>
+          </a:xfrm>
+          <a:prstGeom prst="rect">
+            <a:avLst/>
+          </a:prstGeom>
+          <a:noFill/>
+          <a:ln/>
+        </p:spPr>
+        <p:txBody>
+          <a:bodyPr wrap="square" lIns="0" tIns="0" rIns="0" bIns="0" rtlCol="0" anchor="ctr"/>
+          <a:lstStyle/>
+          <a:p>
+            <a:pPr indent="0" marL="0">
+              <a:buNone/>
+            </a:pPr>
+            <a:r>
+              <a:rPr lang="en-US" sz="1200" b="1" dirty="0">
+                <a:solidFill>
+                  <a:srgbClr val="FFC94D"/>
+                </a:solidFill>
+                <a:latin typeface="Arial" pitchFamily="34" charset="0"/>
+                <a:ea typeface="Arial" pitchFamily="34" charset="-122"/>
+                <a:cs typeface="Arial" pitchFamily="34" charset="-120"/>
+              </a:rPr>
+              <a:t>3주</a:t>
+            </a:r>
+            <a:endParaRPr lang="en-US" sz="1200" dirty="0"/>
+          </a:p>
+        </p:txBody>
+      </p:sp>
+      <p:sp>
+        <p:nvSpPr>
+          <p:cNvPr id="14" name="Text 12"/>
+          <p:cNvSpPr/>
+          <p:nvPr/>
+        </p:nvSpPr>
+        <p:spPr>
+          <a:xfrm>
+            <a:off x="2011680" y="3218688"/>
+            <a:ext cx="6035040" cy="512064"/>
+          </a:xfrm>
+          <a:prstGeom prst="rect">
+            <a:avLst/>
+          </a:prstGeom>
+          <a:noFill/>
+          <a:ln/>
+        </p:spPr>
+        <p:txBody>
+          <a:bodyPr wrap="square" lIns="0" tIns="0" rIns="0" bIns="0" rtlCol="0" anchor="ctr"/>
+          <a:lstStyle/>
+          <a:p>
+            <a:pPr indent="0" marL="0">
+              <a:buNone/>
+            </a:pPr>
+            <a:r>
+              <a:rPr lang="en-US" sz="1100" dirty="0">
                 <a:solidFill>
                   <a:srgbClr val="FFFFFF"/>
                 </a:solidFill>
@@ -5215,38 +5231,38 @@
                 <a:ea typeface="Arial" pitchFamily="34" charset="-122"/>
                 <a:cs typeface="Arial" pitchFamily="34" charset="-120"/>
               </a:rPr>
-              <a:t>다른 모델군 1개 (LLaVA-OneVision) 포팅</a:t>
-            </a:r>
-            <a:endParaRPr lang="en-US" sz="1150" dirty="0"/>
-          </a:p>
-        </p:txBody>
-      </p:sp>
-      <p:sp>
-        <p:nvSpPr>
-          <p:cNvPr id="14" name="Text 12"/>
-          <p:cNvSpPr/>
-          <p:nvPr/>
-        </p:nvSpPr>
-        <p:spPr>
-          <a:xfrm>
-            <a:off x="8183880" y="3273552"/>
-            <a:ext cx="3383280" cy="640080"/>
-          </a:xfrm>
-          <a:prstGeom prst="rect">
-            <a:avLst/>
-          </a:prstGeom>
-          <a:noFill/>
-          <a:ln/>
-        </p:spPr>
-        <p:txBody>
-          <a:bodyPr wrap="square" lIns="0" tIns="0" rIns="0" bIns="0" rtlCol="0" anchor="ctr"/>
-          <a:lstStyle/>
-          <a:p>
-            <a:pPr indent="0" marL="0">
-              <a:buNone/>
-            </a:pPr>
-            <a:r>
-              <a:rPr lang="en-US" sz="1050" dirty="0">
+              <a:t>이번 주 발견에서 나온 개선 — 적응형 개수 / 관련도 비례 차단</a:t>
+            </a:r>
+            <a:endParaRPr lang="en-US" sz="1100" dirty="0"/>
+          </a:p>
+        </p:txBody>
+      </p:sp>
+      <p:sp>
+        <p:nvSpPr>
+          <p:cNvPr id="15" name="Text 13"/>
+          <p:cNvSpPr/>
+          <p:nvPr/>
+        </p:nvSpPr>
+        <p:spPr>
+          <a:xfrm>
+            <a:off x="8183880" y="3218688"/>
+            <a:ext cx="3383280" cy="512064"/>
+          </a:xfrm>
+          <a:prstGeom prst="rect">
+            <a:avLst/>
+          </a:prstGeom>
+          <a:noFill/>
+          <a:ln/>
+        </p:spPr>
+        <p:txBody>
+          <a:bodyPr wrap="square" lIns="0" tIns="0" rIns="0" bIns="0" rtlCol="0" anchor="ctr"/>
+          <a:lstStyle/>
+          <a:p>
+            <a:pPr indent="0" marL="0">
+              <a:buNone/>
+            </a:pPr>
+            <a:r>
+              <a:rPr lang="en-US" sz="1000" dirty="0">
                 <a:solidFill>
                   <a:srgbClr val="9FB8CE"/>
                 </a:solidFill>
@@ -5254,26 +5270,26 @@
                 <a:ea typeface="Arial" pitchFamily="34" charset="-122"/>
                 <a:cs typeface="Arial" pitchFamily="34" charset="-120"/>
               </a:rPr>
-              <a:t>→ 기전이 Qwen 고유물이 아닌가</a:t>
-            </a:r>
-            <a:endParaRPr lang="en-US" sz="1050" dirty="0"/>
-          </a:p>
-        </p:txBody>
-      </p:sp>
-      <p:sp>
-        <p:nvSpPr>
-          <p:cNvPr id="15" name="Shape 13"/>
-          <p:cNvSpPr/>
-          <p:nvPr/>
-        </p:nvSpPr>
-        <p:spPr>
-          <a:xfrm>
-            <a:off x="502920" y="4023360"/>
-            <a:ext cx="11201400" cy="640080"/>
+              <a:t>→ 실현 0.76 → 상한 0.90 격차 줄이기</a:t>
+            </a:r>
+            <a:endParaRPr lang="en-US" sz="1000" dirty="0"/>
+          </a:p>
+        </p:txBody>
+      </p:sp>
+      <p:sp>
+        <p:nvSpPr>
+          <p:cNvPr id="16" name="Shape 14"/>
+          <p:cNvSpPr/>
+          <p:nvPr/>
+        </p:nvSpPr>
+        <p:spPr>
+          <a:xfrm>
+            <a:off x="502920" y="3822192"/>
+            <a:ext cx="11201400" cy="512064"/>
           </a:xfrm>
           <a:prstGeom prst="roundRect">
             <a:avLst>
-              <a:gd name="adj" fmla="val 8571"/>
+              <a:gd name="adj" fmla="val 10714"/>
             </a:avLst>
           </a:prstGeom>
           <a:solidFill>
@@ -5289,30 +5305,30 @@
       </p:sp>
       <p:sp>
         <p:nvSpPr>
-          <p:cNvPr id="16" name="Text 14"/>
-          <p:cNvSpPr/>
-          <p:nvPr/>
-        </p:nvSpPr>
-        <p:spPr>
-          <a:xfrm>
-            <a:off x="731520" y="4023360"/>
-            <a:ext cx="1188720" cy="640080"/>
-          </a:xfrm>
-          <a:prstGeom prst="rect">
-            <a:avLst/>
-          </a:prstGeom>
-          <a:noFill/>
-          <a:ln/>
-        </p:spPr>
-        <p:txBody>
-          <a:bodyPr wrap="square" lIns="0" tIns="0" rIns="0" bIns="0" rtlCol="0" anchor="ctr"/>
-          <a:lstStyle/>
-          <a:p>
-            <a:pPr indent="0" marL="0">
-              <a:buNone/>
-            </a:pPr>
-            <a:r>
-              <a:rPr lang="en-US" sz="1250" b="1" dirty="0">
+          <p:cNvPr id="17" name="Text 15"/>
+          <p:cNvSpPr/>
+          <p:nvPr/>
+        </p:nvSpPr>
+        <p:spPr>
+          <a:xfrm>
+            <a:off x="731520" y="3822192"/>
+            <a:ext cx="1143000" cy="512064"/>
+          </a:xfrm>
+          <a:prstGeom prst="rect">
+            <a:avLst/>
+          </a:prstGeom>
+          <a:noFill/>
+          <a:ln/>
+        </p:spPr>
+        <p:txBody>
+          <a:bodyPr wrap="square" lIns="0" tIns="0" rIns="0" bIns="0" rtlCol="0" anchor="ctr"/>
+          <a:lstStyle/>
+          <a:p>
+            <a:pPr indent="0" marL="0">
+              <a:buNone/>
+            </a:pPr>
+            <a:r>
+              <a:rPr lang="en-US" sz="1200" b="1" dirty="0">
                 <a:solidFill>
                   <a:srgbClr val="7EC8F5"/>
                 </a:solidFill>
@@ -5320,38 +5336,38 @@
                 <a:ea typeface="Arial" pitchFamily="34" charset="-122"/>
                 <a:cs typeface="Arial" pitchFamily="34" charset="-120"/>
               </a:rPr>
-              <a:t>5–7주</a:t>
-            </a:r>
-            <a:endParaRPr lang="en-US" sz="1250" dirty="0"/>
-          </a:p>
-        </p:txBody>
-      </p:sp>
-      <p:sp>
-        <p:nvSpPr>
-          <p:cNvPr id="17" name="Text 15"/>
-          <p:cNvSpPr/>
-          <p:nvPr/>
-        </p:nvSpPr>
-        <p:spPr>
-          <a:xfrm>
-            <a:off x="2057400" y="4023360"/>
-            <a:ext cx="5943600" cy="640080"/>
-          </a:xfrm>
-          <a:prstGeom prst="rect">
-            <a:avLst/>
-          </a:prstGeom>
-          <a:noFill/>
-          <a:ln/>
-        </p:spPr>
-        <p:txBody>
-          <a:bodyPr wrap="square" lIns="0" tIns="0" rIns="0" bIns="0" rtlCol="0" anchor="ctr"/>
-          <a:lstStyle/>
-          <a:p>
-            <a:pPr indent="0" marL="0">
-              <a:buNone/>
-            </a:pPr>
-            <a:r>
-              <a:rPr lang="en-US" sz="1150" dirty="0">
+              <a:t>4–5주</a:t>
+            </a:r>
+            <a:endParaRPr lang="en-US" sz="1200" dirty="0"/>
+          </a:p>
+        </p:txBody>
+      </p:sp>
+      <p:sp>
+        <p:nvSpPr>
+          <p:cNvPr id="18" name="Text 16"/>
+          <p:cNvSpPr/>
+          <p:nvPr/>
+        </p:nvSpPr>
+        <p:spPr>
+          <a:xfrm>
+            <a:off x="2011680" y="3822192"/>
+            <a:ext cx="6035040" cy="512064"/>
+          </a:xfrm>
+          <a:prstGeom prst="rect">
+            <a:avLst/>
+          </a:prstGeom>
+          <a:noFill/>
+          <a:ln/>
+        </p:spPr>
+        <p:txBody>
+          <a:bodyPr wrap="square" lIns="0" tIns="0" rIns="0" bIns="0" rtlCol="0" anchor="ctr"/>
+          <a:lstStyle/>
+          <a:p>
+            <a:pPr indent="0" marL="0">
+              <a:buNone/>
+            </a:pPr>
+            <a:r>
+              <a:rPr lang="en-US" sz="1100" dirty="0">
                 <a:solidFill>
                   <a:srgbClr val="FFFFFF"/>
                 </a:solidFill>
@@ -5359,38 +5375,38 @@
                 <a:ea typeface="Arial" pitchFamily="34" charset="-122"/>
                 <a:cs typeface="Arial" pitchFamily="34" charset="-120"/>
               </a:rPr>
-              <a:t>FOCUS 공식 코드 정식 재현 · 인코더 재사용 구현 후 실측 속도 · 생성 평가</a:t>
-            </a:r>
-            <a:endParaRPr lang="en-US" sz="1150" dirty="0"/>
-          </a:p>
-        </p:txBody>
-      </p:sp>
-      <p:sp>
-        <p:nvSpPr>
-          <p:cNvPr id="18" name="Text 16"/>
-          <p:cNvSpPr/>
-          <p:nvPr/>
-        </p:nvSpPr>
-        <p:spPr>
-          <a:xfrm>
-            <a:off x="8183880" y="4023360"/>
-            <a:ext cx="3383280" cy="640080"/>
-          </a:xfrm>
-          <a:prstGeom prst="rect">
-            <a:avLst/>
-          </a:prstGeom>
-          <a:noFill/>
-          <a:ln/>
-        </p:spPr>
-        <p:txBody>
-          <a:bodyPr wrap="square" lIns="0" tIns="0" rIns="0" bIns="0" rtlCol="0" anchor="ctr"/>
-          <a:lstStyle/>
-          <a:p>
-            <a:pPr indent="0" marL="0">
-              <a:buNone/>
-            </a:pPr>
-            <a:r>
-              <a:rPr lang="en-US" sz="1050" dirty="0">
+              <a:t>다른 모델군 (InternVL3 · LLaVA-OneVision — FOCUS가 쓴 것과 동일)</a:t>
+            </a:r>
+            <a:endParaRPr lang="en-US" sz="1100" dirty="0"/>
+          </a:p>
+        </p:txBody>
+      </p:sp>
+      <p:sp>
+        <p:nvSpPr>
+          <p:cNvPr id="19" name="Text 17"/>
+          <p:cNvSpPr/>
+          <p:nvPr/>
+        </p:nvSpPr>
+        <p:spPr>
+          <a:xfrm>
+            <a:off x="8183880" y="3822192"/>
+            <a:ext cx="3383280" cy="512064"/>
+          </a:xfrm>
+          <a:prstGeom prst="rect">
+            <a:avLst/>
+          </a:prstGeom>
+          <a:noFill/>
+          <a:ln/>
+        </p:spPr>
+        <p:txBody>
+          <a:bodyPr wrap="square" lIns="0" tIns="0" rIns="0" bIns="0" rtlCol="0" anchor="ctr"/>
+          <a:lstStyle/>
+          <a:p>
+            <a:pPr indent="0" marL="0">
+              <a:buNone/>
+            </a:pPr>
+            <a:r>
+              <a:rPr lang="en-US" sz="1000" dirty="0">
                 <a:solidFill>
                   <a:srgbClr val="9FB8CE"/>
                 </a:solidFill>
@@ -5398,26 +5414,26 @@
                 <a:ea typeface="Arial" pitchFamily="34" charset="-122"/>
                 <a:cs typeface="Arial" pitchFamily="34" charset="-120"/>
               </a:rPr>
-              <a:t>→ 비교의 정당성 확보 / 예-아니오 논문 탈피</a:t>
-            </a:r>
-            <a:endParaRPr lang="en-US" sz="1050" dirty="0"/>
-          </a:p>
-        </p:txBody>
-      </p:sp>
-      <p:sp>
-        <p:nvSpPr>
-          <p:cNvPr id="19" name="Shape 17"/>
-          <p:cNvSpPr/>
-          <p:nvPr/>
-        </p:nvSpPr>
-        <p:spPr>
-          <a:xfrm>
-            <a:off x="502920" y="4773168"/>
-            <a:ext cx="11201400" cy="640080"/>
+              <a:t>→ 기전이 Qwen 고유물이 아닌가</a:t>
+            </a:r>
+            <a:endParaRPr lang="en-US" sz="1000" dirty="0"/>
+          </a:p>
+        </p:txBody>
+      </p:sp>
+      <p:sp>
+        <p:nvSpPr>
+          <p:cNvPr id="20" name="Shape 18"/>
+          <p:cNvSpPr/>
+          <p:nvPr/>
+        </p:nvSpPr>
+        <p:spPr>
+          <a:xfrm>
+            <a:off x="502920" y="4425696"/>
+            <a:ext cx="11201400" cy="512064"/>
           </a:xfrm>
           <a:prstGeom prst="roundRect">
             <a:avLst>
-              <a:gd name="adj" fmla="val 8571"/>
+              <a:gd name="adj" fmla="val 10714"/>
             </a:avLst>
           </a:prstGeom>
           <a:solidFill>
@@ -5433,69 +5449,69 @@
       </p:sp>
       <p:sp>
         <p:nvSpPr>
-          <p:cNvPr id="20" name="Text 18"/>
-          <p:cNvSpPr/>
-          <p:nvPr/>
-        </p:nvSpPr>
-        <p:spPr>
-          <a:xfrm>
-            <a:off x="731520" y="4773168"/>
-            <a:ext cx="1188720" cy="640080"/>
-          </a:xfrm>
-          <a:prstGeom prst="rect">
-            <a:avLst/>
-          </a:prstGeom>
-          <a:noFill/>
-          <a:ln/>
-        </p:spPr>
-        <p:txBody>
-          <a:bodyPr wrap="square" lIns="0" tIns="0" rIns="0" bIns="0" rtlCol="0" anchor="ctr"/>
-          <a:lstStyle/>
-          <a:p>
-            <a:pPr indent="0" marL="0">
-              <a:buNone/>
-            </a:pPr>
-            <a:r>
-              <a:rPr lang="en-US" sz="1250" b="1" dirty="0">
-                <a:solidFill>
-                  <a:srgbClr val="8CE0B0"/>
-                </a:solidFill>
-                <a:latin typeface="Arial" pitchFamily="34" charset="0"/>
-                <a:ea typeface="Arial" pitchFamily="34" charset="-122"/>
-                <a:cs typeface="Arial" pitchFamily="34" charset="-120"/>
-              </a:rPr>
-              <a:t>8–11주</a:t>
-            </a:r>
-            <a:endParaRPr lang="en-US" sz="1250" dirty="0"/>
-          </a:p>
-        </p:txBody>
-      </p:sp>
-      <p:sp>
-        <p:nvSpPr>
           <p:cNvPr id="21" name="Text 19"/>
           <p:cNvSpPr/>
           <p:nvPr/>
         </p:nvSpPr>
         <p:spPr>
           <a:xfrm>
-            <a:off x="2057400" y="4773168"/>
-            <a:ext cx="5943600" cy="640080"/>
-          </a:xfrm>
-          <a:prstGeom prst="rect">
-            <a:avLst/>
-          </a:prstGeom>
-          <a:noFill/>
-          <a:ln/>
-        </p:spPr>
-        <p:txBody>
-          <a:bodyPr wrap="square" lIns="0" tIns="0" rIns="0" bIns="0" rtlCol="0" anchor="ctr"/>
-          <a:lstStyle/>
-          <a:p>
-            <a:pPr indent="0" marL="0">
-              <a:buNone/>
-            </a:pPr>
-            <a:r>
-              <a:rPr lang="en-US" sz="1150" dirty="0">
+            <a:off x="731520" y="4425696"/>
+            <a:ext cx="1143000" cy="512064"/>
+          </a:xfrm>
+          <a:prstGeom prst="rect">
+            <a:avLst/>
+          </a:prstGeom>
+          <a:noFill/>
+          <a:ln/>
+        </p:spPr>
+        <p:txBody>
+          <a:bodyPr wrap="square" lIns="0" tIns="0" rIns="0" bIns="0" rtlCol="0" anchor="ctr"/>
+          <a:lstStyle/>
+          <a:p>
+            <a:pPr indent="0" marL="0">
+              <a:buNone/>
+            </a:pPr>
+            <a:r>
+              <a:rPr lang="en-US" sz="1200" b="1" dirty="0">
+                <a:solidFill>
+                  <a:srgbClr val="7EC8F5"/>
+                </a:solidFill>
+                <a:latin typeface="Arial" pitchFamily="34" charset="0"/>
+                <a:ea typeface="Arial" pitchFamily="34" charset="-122"/>
+                <a:cs typeface="Arial" pitchFamily="34" charset="-120"/>
+              </a:rPr>
+              <a:t>6–8주</a:t>
+            </a:r>
+            <a:endParaRPr lang="en-US" sz="1200" dirty="0"/>
+          </a:p>
+        </p:txBody>
+      </p:sp>
+      <p:sp>
+        <p:nvSpPr>
+          <p:cNvPr id="22" name="Text 20"/>
+          <p:cNvSpPr/>
+          <p:nvPr/>
+        </p:nvSpPr>
+        <p:spPr>
+          <a:xfrm>
+            <a:off x="2011680" y="4425696"/>
+            <a:ext cx="6035040" cy="512064"/>
+          </a:xfrm>
+          <a:prstGeom prst="rect">
+            <a:avLst/>
+          </a:prstGeom>
+          <a:noFill/>
+          <a:ln/>
+        </p:spPr>
+        <p:txBody>
+          <a:bodyPr wrap="square" lIns="0" tIns="0" rIns="0" bIns="0" rtlCol="0" anchor="ctr"/>
+          <a:lstStyle/>
+          <a:p>
+            <a:pPr indent="0" marL="0">
+              <a:buNone/>
+            </a:pPr>
+            <a:r>
+              <a:rPr lang="en-US" sz="1100" dirty="0">
                 <a:solidFill>
                   <a:srgbClr val="FFFFFF"/>
                 </a:solidFill>
@@ -5503,38 +5519,38 @@
                 <a:ea typeface="Arial" pitchFamily="34" charset="-122"/>
                 <a:cs typeface="Arial" pitchFamily="34" charset="-120"/>
               </a:rPr>
-              <a:t>초고 → 내부 리뷰 2회 → 초록 11/06 → 제출 11/13</a:t>
-            </a:r>
-            <a:endParaRPr lang="en-US" sz="1150" dirty="0"/>
-          </a:p>
-        </p:txBody>
-      </p:sp>
-      <p:sp>
-        <p:nvSpPr>
-          <p:cNvPr id="22" name="Text 20"/>
-          <p:cNvSpPr/>
-          <p:nvPr/>
-        </p:nvSpPr>
-        <p:spPr>
-          <a:xfrm>
-            <a:off x="8183880" y="4773168"/>
-            <a:ext cx="3383280" cy="640080"/>
-          </a:xfrm>
-          <a:prstGeom prst="rect">
-            <a:avLst/>
-          </a:prstGeom>
-          <a:noFill/>
-          <a:ln/>
-        </p:spPr>
-        <p:txBody>
-          <a:bodyPr wrap="square" lIns="0" tIns="0" rIns="0" bIns="0" rtlCol="0" anchor="ctr"/>
-          <a:lstStyle/>
-          <a:p>
-            <a:pPr indent="0" marL="0">
-              <a:buNone/>
-            </a:pPr>
-            <a:r>
-              <a:rPr lang="en-US" sz="1050" dirty="0">
+              <a:t>생성 평가 (Winoground · VisMin) · 인코더 재사용 후 실측 속도</a:t>
+            </a:r>
+            <a:endParaRPr lang="en-US" sz="1100" dirty="0"/>
+          </a:p>
+        </p:txBody>
+      </p:sp>
+      <p:sp>
+        <p:nvSpPr>
+          <p:cNvPr id="23" name="Text 21"/>
+          <p:cNvSpPr/>
+          <p:nvPr/>
+        </p:nvSpPr>
+        <p:spPr>
+          <a:xfrm>
+            <a:off x="8183880" y="4425696"/>
+            <a:ext cx="3383280" cy="512064"/>
+          </a:xfrm>
+          <a:prstGeom prst="rect">
+            <a:avLst/>
+          </a:prstGeom>
+          <a:noFill/>
+          <a:ln/>
+        </p:spPr>
+        <p:txBody>
+          <a:bodyPr wrap="square" lIns="0" tIns="0" rIns="0" bIns="0" rtlCol="0" anchor="ctr"/>
+          <a:lstStyle/>
+          <a:p>
+            <a:pPr indent="0" marL="0">
+              <a:buNone/>
+            </a:pPr>
+            <a:r>
+              <a:rPr lang="en-US" sz="1000" dirty="0">
                 <a:solidFill>
                   <a:srgbClr val="9FB8CE"/>
                 </a:solidFill>
@@ -5542,26 +5558,170 @@
                 <a:ea typeface="Arial" pitchFamily="34" charset="-122"/>
                 <a:cs typeface="Arial" pitchFamily="34" charset="-120"/>
               </a:rPr>
-              <a:t>→ —</a:t>
-            </a:r>
-            <a:endParaRPr lang="en-US" sz="1050" dirty="0"/>
-          </a:p>
-        </p:txBody>
-      </p:sp>
-      <p:sp>
-        <p:nvSpPr>
-          <p:cNvPr id="23" name="Shape 21"/>
-          <p:cNvSpPr/>
-          <p:nvPr/>
-        </p:nvSpPr>
-        <p:spPr>
-          <a:xfrm>
-            <a:off x="502920" y="5614416"/>
-            <a:ext cx="11201400" cy="786384"/>
+              <a:t>→ 예-아니오 논문 탈피 / 비용 주장 확정</a:t>
+            </a:r>
+            <a:endParaRPr lang="en-US" sz="1000" dirty="0"/>
+          </a:p>
+        </p:txBody>
+      </p:sp>
+      <p:sp>
+        <p:nvSpPr>
+          <p:cNvPr id="24" name="Shape 22"/>
+          <p:cNvSpPr/>
+          <p:nvPr/>
+        </p:nvSpPr>
+        <p:spPr>
+          <a:xfrm>
+            <a:off x="502920" y="5029200"/>
+            <a:ext cx="11201400" cy="512064"/>
           </a:xfrm>
           <a:prstGeom prst="roundRect">
             <a:avLst>
-              <a:gd name="adj" fmla="val 6977"/>
+              <a:gd name="adj" fmla="val 10714"/>
+            </a:avLst>
+          </a:prstGeom>
+          <a:solidFill>
+            <a:srgbClr val="1D3850"/>
+          </a:solidFill>
+          <a:ln w="12700">
+            <a:solidFill>
+              <a:srgbClr val="2E4E6B"/>
+            </a:solidFill>
+            <a:prstDash val="solid"/>
+          </a:ln>
+        </p:spPr>
+      </p:sp>
+      <p:sp>
+        <p:nvSpPr>
+          <p:cNvPr id="25" name="Text 23"/>
+          <p:cNvSpPr/>
+          <p:nvPr/>
+        </p:nvSpPr>
+        <p:spPr>
+          <a:xfrm>
+            <a:off x="731520" y="5029200"/>
+            <a:ext cx="1143000" cy="512064"/>
+          </a:xfrm>
+          <a:prstGeom prst="rect">
+            <a:avLst/>
+          </a:prstGeom>
+          <a:noFill/>
+          <a:ln/>
+        </p:spPr>
+        <p:txBody>
+          <a:bodyPr wrap="square" lIns="0" tIns="0" rIns="0" bIns="0" rtlCol="0" anchor="ctr"/>
+          <a:lstStyle/>
+          <a:p>
+            <a:pPr indent="0" marL="0">
+              <a:buNone/>
+            </a:pPr>
+            <a:r>
+              <a:rPr lang="en-US" sz="1200" b="1" dirty="0">
+                <a:solidFill>
+                  <a:srgbClr val="8CE0B0"/>
+                </a:solidFill>
+                <a:latin typeface="Arial" pitchFamily="34" charset="0"/>
+                <a:ea typeface="Arial" pitchFamily="34" charset="-122"/>
+                <a:cs typeface="Arial" pitchFamily="34" charset="-120"/>
+              </a:rPr>
+              <a:t>9–11주</a:t>
+            </a:r>
+            <a:endParaRPr lang="en-US" sz="1200" dirty="0"/>
+          </a:p>
+        </p:txBody>
+      </p:sp>
+      <p:sp>
+        <p:nvSpPr>
+          <p:cNvPr id="26" name="Text 24"/>
+          <p:cNvSpPr/>
+          <p:nvPr/>
+        </p:nvSpPr>
+        <p:spPr>
+          <a:xfrm>
+            <a:off x="2011680" y="5029200"/>
+            <a:ext cx="6035040" cy="512064"/>
+          </a:xfrm>
+          <a:prstGeom prst="rect">
+            <a:avLst/>
+          </a:prstGeom>
+          <a:noFill/>
+          <a:ln/>
+        </p:spPr>
+        <p:txBody>
+          <a:bodyPr wrap="square" lIns="0" tIns="0" rIns="0" bIns="0" rtlCol="0" anchor="ctr"/>
+          <a:lstStyle/>
+          <a:p>
+            <a:pPr indent="0" marL="0">
+              <a:buNone/>
+            </a:pPr>
+            <a:r>
+              <a:rPr lang="en-US" sz="1100" dirty="0">
+                <a:solidFill>
+                  <a:srgbClr val="FFFFFF"/>
+                </a:solidFill>
+                <a:latin typeface="Arial" pitchFamily="34" charset="0"/>
+                <a:ea typeface="Arial" pitchFamily="34" charset="-122"/>
+                <a:cs typeface="Arial" pitchFamily="34" charset="-120"/>
+              </a:rPr>
+              <a:t>초고 → 내부 리뷰 2회 → 초록 11/06 → 제출 11/13</a:t>
+            </a:r>
+            <a:endParaRPr lang="en-US" sz="1100" dirty="0"/>
+          </a:p>
+        </p:txBody>
+      </p:sp>
+      <p:sp>
+        <p:nvSpPr>
+          <p:cNvPr id="27" name="Text 25"/>
+          <p:cNvSpPr/>
+          <p:nvPr/>
+        </p:nvSpPr>
+        <p:spPr>
+          <a:xfrm>
+            <a:off x="8183880" y="5029200"/>
+            <a:ext cx="3383280" cy="512064"/>
+          </a:xfrm>
+          <a:prstGeom prst="rect">
+            <a:avLst/>
+          </a:prstGeom>
+          <a:noFill/>
+          <a:ln/>
+        </p:spPr>
+        <p:txBody>
+          <a:bodyPr wrap="square" lIns="0" tIns="0" rIns="0" bIns="0" rtlCol="0" anchor="ctr"/>
+          <a:lstStyle/>
+          <a:p>
+            <a:pPr indent="0" marL="0">
+              <a:buNone/>
+            </a:pPr>
+            <a:r>
+              <a:rPr lang="en-US" sz="1000" dirty="0">
+                <a:solidFill>
+                  <a:srgbClr val="9FB8CE"/>
+                </a:solidFill>
+                <a:latin typeface="Arial" pitchFamily="34" charset="0"/>
+                <a:ea typeface="Arial" pitchFamily="34" charset="-122"/>
+                <a:cs typeface="Arial" pitchFamily="34" charset="-120"/>
+              </a:rPr>
+              <a:t>→ —</a:t>
+            </a:r>
+            <a:endParaRPr lang="en-US" sz="1000" dirty="0"/>
+          </a:p>
+        </p:txBody>
+      </p:sp>
+      <p:sp>
+        <p:nvSpPr>
+          <p:cNvPr id="28" name="Shape 26"/>
+          <p:cNvSpPr/>
+          <p:nvPr/>
+        </p:nvSpPr>
+        <p:spPr>
+          <a:xfrm>
+            <a:off x="502920" y="5705856"/>
+            <a:ext cx="11201400" cy="713232"/>
+          </a:xfrm>
+          <a:prstGeom prst="roundRect">
+            <a:avLst>
+              <a:gd name="adj" fmla="val 7692"/>
             </a:avLst>
           </a:prstGeom>
           <a:solidFill>
@@ -5577,13 +5737,13 @@
       </p:sp>
       <p:sp>
         <p:nvSpPr>
-          <p:cNvPr id="24" name="Text 22"/>
-          <p:cNvSpPr/>
-          <p:nvPr/>
-        </p:nvSpPr>
-        <p:spPr>
-          <a:xfrm>
-            <a:off x="777240" y="5705856"/>
+          <p:cNvPr id="29" name="Text 27"/>
+          <p:cNvSpPr/>
+          <p:nvPr/>
+        </p:nvSpPr>
+        <p:spPr>
+          <a:xfrm>
+            <a:off x="777240" y="5797296"/>
             <a:ext cx="10698480" cy="256032"/>
           </a:xfrm>
           <a:prstGeom prst="rect">
@@ -5600,7 +5760,7 @@
               <a:buNone/>
             </a:pPr>
             <a:r>
-              <a:rPr lang="en-US" sz="1200" b="1" dirty="0">
+              <a:rPr lang="en-US" sz="1150" b="1" dirty="0">
                 <a:solidFill>
                   <a:srgbClr val="FFB4A2"/>
                 </a:solidFill>
@@ -5608,21 +5768,21 @@
                 <a:ea typeface="Arial" pitchFamily="34" charset="-122"/>
                 <a:cs typeface="Arial" pitchFamily="34" charset="-120"/>
               </a:rPr>
-              <a:t>가장 큰 위험: 지금 모든 결과가 저희가 만든 COCO 기반 벤치와 예/아니오 단답에 한정됩니다.</a:t>
-            </a:r>
-            <a:endParaRPr lang="en-US" sz="1200" dirty="0"/>
-          </a:p>
-        </p:txBody>
-      </p:sp>
-      <p:sp>
-        <p:nvSpPr>
-          <p:cNvPr id="25" name="Text 23"/>
-          <p:cNvSpPr/>
-          <p:nvPr/>
-        </p:nvSpPr>
-        <p:spPr>
-          <a:xfrm>
-            <a:off x="777240" y="5998464"/>
+              <a:t>중단 조건: 같은 벤치·같은 모델에서 FOCUS를 넘지 못하면, 방법 논문이 아니라 기전 분석 논문으로 방향을 바꿉니다.</a:t>
+            </a:r>
+            <a:endParaRPr lang="en-US" sz="1150" dirty="0"/>
+          </a:p>
+        </p:txBody>
+      </p:sp>
+      <p:sp>
+        <p:nvSpPr>
+          <p:cNvPr id="30" name="Text 28"/>
+          <p:cNvSpPr/>
+          <p:nvPr/>
+        </p:nvSpPr>
+        <p:spPr>
+          <a:xfrm>
+            <a:off x="777240" y="6071616"/>
             <a:ext cx="10698480" cy="256032"/>
           </a:xfrm>
           <a:prstGeom prst="rect">
@@ -5639,7 +5799,7 @@
               <a:buNone/>
             </a:pPr>
             <a:r>
-              <a:rPr lang="en-US" sz="1100" dirty="0">
+              <a:rPr lang="en-US" sz="1050" dirty="0">
                 <a:solidFill>
                   <a:srgbClr val="D0BCC4"/>
                 </a:solidFill>
@@ -5647,9 +5807,9 @@
                 <a:ea typeface="Arial" pitchFamily="34" charset="-122"/>
                 <a:cs typeface="Arial" pitchFamily="34" charset="-120"/>
               </a:rPr>
-              <a:t>공개 벤치마크에서 재현되지 않으면 2주차에 접겠습니다. 그 판정 기준을 지금 문서로 고정해두겠습니다.</a:t>
-            </a:r>
-            <a:endParaRPr lang="en-US" sz="1100" dirty="0"/>
+              <a:t>지금 모든 결과가 저희가 만든 벤치와 예/아니오 단답에 한정되어 있다는 점이 가장 큰 위험입니다.</a:t>
+            </a:r>
+            <a:endParaRPr lang="en-US" sz="1050" dirty="0"/>
           </a:p>
         </p:txBody>
       </p:sp>

</xml_diff>